<commit_message>
CAUSEWAY-3990 : staging changes to website
</commit_message>
<xml_diff>
--- a/content/docs/latest/starters/_attachments/simpleapp-modules-dependencies.pptx
+++ b/content/docs/latest/starters/_attachments/simpleapp-modules-dependencies.pptx
@@ -261,7 +261,7 @@
           <a:p>
             <a:fld id="{3159BD86-569B-442C-ABE1-0B002BE59BAD}" type="datetimeFigureOut">
               <a:rPr lang="en-GB" smtClean="0"/>
-              <a:t>12/03/2023</a:t>
+              <a:t>18/10/2025</a:t>
             </a:fld>
             <a:endParaRPr lang="en-GB"/>
           </a:p>
@@ -461,7 +461,7 @@
           <a:p>
             <a:fld id="{3159BD86-569B-442C-ABE1-0B002BE59BAD}" type="datetimeFigureOut">
               <a:rPr lang="en-GB" smtClean="0"/>
-              <a:t>12/03/2023</a:t>
+              <a:t>18/10/2025</a:t>
             </a:fld>
             <a:endParaRPr lang="en-GB"/>
           </a:p>
@@ -671,7 +671,7 @@
           <a:p>
             <a:fld id="{3159BD86-569B-442C-ABE1-0B002BE59BAD}" type="datetimeFigureOut">
               <a:rPr lang="en-GB" smtClean="0"/>
-              <a:t>12/03/2023</a:t>
+              <a:t>18/10/2025</a:t>
             </a:fld>
             <a:endParaRPr lang="en-GB"/>
           </a:p>
@@ -871,7 +871,7 @@
           <a:p>
             <a:fld id="{3159BD86-569B-442C-ABE1-0B002BE59BAD}" type="datetimeFigureOut">
               <a:rPr lang="en-GB" smtClean="0"/>
-              <a:t>12/03/2023</a:t>
+              <a:t>18/10/2025</a:t>
             </a:fld>
             <a:endParaRPr lang="en-GB"/>
           </a:p>
@@ -1147,7 +1147,7 @@
           <a:p>
             <a:fld id="{3159BD86-569B-442C-ABE1-0B002BE59BAD}" type="datetimeFigureOut">
               <a:rPr lang="en-GB" smtClean="0"/>
-              <a:t>12/03/2023</a:t>
+              <a:t>18/10/2025</a:t>
             </a:fld>
             <a:endParaRPr lang="en-GB"/>
           </a:p>
@@ -1415,7 +1415,7 @@
           <a:p>
             <a:fld id="{3159BD86-569B-442C-ABE1-0B002BE59BAD}" type="datetimeFigureOut">
               <a:rPr lang="en-GB" smtClean="0"/>
-              <a:t>12/03/2023</a:t>
+              <a:t>18/10/2025</a:t>
             </a:fld>
             <a:endParaRPr lang="en-GB"/>
           </a:p>
@@ -1830,7 +1830,7 @@
           <a:p>
             <a:fld id="{3159BD86-569B-442C-ABE1-0B002BE59BAD}" type="datetimeFigureOut">
               <a:rPr lang="en-GB" smtClean="0"/>
-              <a:t>12/03/2023</a:t>
+              <a:t>18/10/2025</a:t>
             </a:fld>
             <a:endParaRPr lang="en-GB"/>
           </a:p>
@@ -1972,7 +1972,7 @@
           <a:p>
             <a:fld id="{3159BD86-569B-442C-ABE1-0B002BE59BAD}" type="datetimeFigureOut">
               <a:rPr lang="en-GB" smtClean="0"/>
-              <a:t>12/03/2023</a:t>
+              <a:t>18/10/2025</a:t>
             </a:fld>
             <a:endParaRPr lang="en-GB"/>
           </a:p>
@@ -2085,7 +2085,7 @@
           <a:p>
             <a:fld id="{3159BD86-569B-442C-ABE1-0B002BE59BAD}" type="datetimeFigureOut">
               <a:rPr lang="en-GB" smtClean="0"/>
-              <a:t>12/03/2023</a:t>
+              <a:t>18/10/2025</a:t>
             </a:fld>
             <a:endParaRPr lang="en-GB"/>
           </a:p>
@@ -2398,7 +2398,7 @@
           <a:p>
             <a:fld id="{3159BD86-569B-442C-ABE1-0B002BE59BAD}" type="datetimeFigureOut">
               <a:rPr lang="en-GB" smtClean="0"/>
-              <a:t>12/03/2023</a:t>
+              <a:t>18/10/2025</a:t>
             </a:fld>
             <a:endParaRPr lang="en-GB"/>
           </a:p>
@@ -2687,7 +2687,7 @@
           <a:p>
             <a:fld id="{3159BD86-569B-442C-ABE1-0B002BE59BAD}" type="datetimeFigureOut">
               <a:rPr lang="en-GB" smtClean="0"/>
-              <a:t>12/03/2023</a:t>
+              <a:t>18/10/2025</a:t>
             </a:fld>
             <a:endParaRPr lang="en-GB"/>
           </a:p>
@@ -2930,7 +2930,7 @@
           <a:p>
             <a:fld id="{3159BD86-569B-442C-ABE1-0B002BE59BAD}" type="datetimeFigureOut">
               <a:rPr lang="en-GB" smtClean="0"/>
-              <a:t>12/03/2023</a:t>
+              <a:t>18/10/2025</a:t>
             </a:fld>
             <a:endParaRPr lang="en-GB"/>
           </a:p>
@@ -3873,14 +3873,14 @@
             <a:pPr algn="ctr"/>
             <a:r>
               <a:rPr lang="en-GB" sz="1200" dirty="0" err="1"/>
-              <a:t>Jdo</a:t>
+              <a:t>Jpa</a:t>
             </a:r>
             <a:br>
-              <a:rPr lang="en-GB" sz="1200"/>
+              <a:rPr lang="en-GB" sz="1200" dirty="0"/>
             </a:br>
             <a:r>
-              <a:rPr lang="en-GB" sz="1200"/>
-              <a:t>DataNucleus</a:t>
+              <a:rPr lang="en-GB" sz="1200" dirty="0" err="1"/>
+              <a:t>EclipseLink</a:t>
             </a:r>
             <a:endParaRPr lang="en-GB" sz="1200" dirty="0"/>
           </a:p>
@@ -3985,7 +3985,7 @@
             </a:br>
             <a:r>
               <a:rPr lang="en-GB" sz="1200" dirty="0"/>
-              <a:t>Shiro</a:t>
+              <a:t>Simple</a:t>
             </a:r>
           </a:p>
         </p:txBody>
@@ -4113,7 +4113,7 @@
         </p:nvSpPr>
         <p:spPr>
           <a:xfrm>
-            <a:off x="5250398" y="5568914"/>
+            <a:off x="5270067" y="5539782"/>
             <a:ext cx="1240231" cy="486032"/>
           </a:xfrm>
           <a:prstGeom prst="rect">
@@ -4149,13 +4149,12 @@
               <a:t>Restful Objects</a:t>
             </a:r>
             <a:br>
-              <a:rPr lang="en-GB" sz="1200"/>
+              <a:rPr lang="en-GB" sz="1200" dirty="0"/>
             </a:br>
             <a:r>
-              <a:rPr lang="en-GB" sz="1200"/>
-              <a:t>JaxrsResteasy</a:t>
-            </a:r>
-            <a:endParaRPr lang="en-GB" sz="1200" dirty="0"/>
+              <a:rPr lang="en-GB" sz="1200" dirty="0"/>
+              <a:t>Viewer</a:t>
+            </a:r>
           </a:p>
         </p:txBody>
       </p:sp>
@@ -4310,8 +4309,8 @@
         </p:nvCxnSpPr>
         <p:spPr>
           <a:xfrm rot="5400000">
-            <a:off x="6407614" y="5362376"/>
-            <a:ext cx="532569" cy="366538"/>
+            <a:off x="6432015" y="5357645"/>
+            <a:ext cx="503437" cy="346869"/>
           </a:xfrm>
           <a:prstGeom prst="curvedConnector2">
             <a:avLst/>
@@ -5086,18 +5085,20 @@
           </p:cNvPr>
           <p:cNvCxnSpPr>
             <a:cxnSpLocks/>
-            <a:stCxn id="175" idx="4"/>
-            <a:endCxn id="92" idx="3"/>
+            <a:stCxn id="175" idx="5"/>
+            <a:endCxn id="92" idx="0"/>
           </p:cNvCxnSpPr>
           <p:nvPr/>
         </p:nvCxnSpPr>
         <p:spPr>
-          <a:xfrm rot="5400000">
-            <a:off x="6126037" y="5671677"/>
-            <a:ext cx="1146321" cy="417136"/>
-          </a:xfrm>
-          <a:prstGeom prst="curvedConnector2">
-            <a:avLst/>
+          <a:xfrm rot="16200000" flipH="1">
+            <a:off x="6942600" y="5295123"/>
+            <a:ext cx="841068" cy="809543"/>
+          </a:xfrm>
+          <a:prstGeom prst="curvedConnector3">
+            <a:avLst>
+              <a:gd name="adj1" fmla="val 50000"/>
+            </a:avLst>
           </a:prstGeom>
           <a:ln>
             <a:tailEnd type="triangle"/>
@@ -5494,7 +5495,7 @@
         </p:nvSpPr>
         <p:spPr>
           <a:xfrm>
-            <a:off x="5250398" y="6210390"/>
+            <a:off x="7147790" y="6120429"/>
             <a:ext cx="1240231" cy="486032"/>
           </a:xfrm>
           <a:prstGeom prst="rect">
@@ -6496,6 +6497,108 @@
           </a:p>
         </p:txBody>
       </p:sp>
+      <p:sp>
+        <p:nvSpPr>
+          <p:cNvPr id="3" name="Rectangle 2">
+            <a:extLst>
+              <a:ext uri="{FF2B5EF4-FFF2-40B4-BE49-F238E27FC236}">
+                <a16:creationId xmlns:a16="http://schemas.microsoft.com/office/drawing/2014/main" id="{CC22014F-97AF-6A8E-240A-B956C68D3ECF}"/>
+              </a:ext>
+            </a:extLst>
+          </p:cNvPr>
+          <p:cNvSpPr/>
+          <p:nvPr/>
+        </p:nvSpPr>
+        <p:spPr>
+          <a:xfrm>
+            <a:off x="5250398" y="6110150"/>
+            <a:ext cx="1240231" cy="486032"/>
+          </a:xfrm>
+          <a:prstGeom prst="rect">
+            <a:avLst/>
+          </a:prstGeom>
+          <a:solidFill>
+            <a:srgbClr val="7030A0"/>
+          </a:solidFill>
+        </p:spPr>
+        <p:style>
+          <a:lnRef idx="2">
+            <a:schemeClr val="accent1">
+              <a:shade val="50000"/>
+            </a:schemeClr>
+          </a:lnRef>
+          <a:fillRef idx="1">
+            <a:schemeClr val="accent1"/>
+          </a:fillRef>
+          <a:effectRef idx="0">
+            <a:schemeClr val="accent1"/>
+          </a:effectRef>
+          <a:fontRef idx="minor">
+            <a:schemeClr val="lt1"/>
+          </a:fontRef>
+        </p:style>
+        <p:txBody>
+          <a:bodyPr rtlCol="0" anchor="ctr"/>
+          <a:lstStyle/>
+          <a:p>
+            <a:pPr algn="ctr"/>
+            <a:r>
+              <a:rPr lang="en-GB" sz="1200" dirty="0" err="1"/>
+              <a:t>GraphqL</a:t>
+            </a:r>
+            <a:br>
+              <a:rPr lang="en-GB" sz="1200" dirty="0"/>
+            </a:br>
+            <a:r>
+              <a:rPr lang="en-GB" sz="1200" dirty="0"/>
+              <a:t>Viewer</a:t>
+            </a:r>
+          </a:p>
+        </p:txBody>
+      </p:sp>
+      <p:cxnSp>
+        <p:nvCxnSpPr>
+          <p:cNvPr id="8" name="Connector: Curved 179">
+            <a:extLst>
+              <a:ext uri="{FF2B5EF4-FFF2-40B4-BE49-F238E27FC236}">
+                <a16:creationId xmlns:a16="http://schemas.microsoft.com/office/drawing/2014/main" id="{17A6AA03-9C1B-89AE-E08B-F8F843CFAF37}"/>
+              </a:ext>
+            </a:extLst>
+          </p:cNvPr>
+          <p:cNvCxnSpPr>
+            <a:cxnSpLocks/>
+            <a:stCxn id="175" idx="4"/>
+            <a:endCxn id="3" idx="3"/>
+          </p:cNvCxnSpPr>
+          <p:nvPr/>
+        </p:nvCxnSpPr>
+        <p:spPr>
+          <a:xfrm rot="5400000">
+            <a:off x="6176157" y="5621557"/>
+            <a:ext cx="1046081" cy="417136"/>
+          </a:xfrm>
+          <a:prstGeom prst="curvedConnector2">
+            <a:avLst/>
+          </a:prstGeom>
+          <a:ln>
+            <a:tailEnd type="triangle"/>
+          </a:ln>
+        </p:spPr>
+        <p:style>
+          <a:lnRef idx="1">
+            <a:schemeClr val="accent1"/>
+          </a:lnRef>
+          <a:fillRef idx="0">
+            <a:schemeClr val="accent1"/>
+          </a:fillRef>
+          <a:effectRef idx="0">
+            <a:schemeClr val="accent1"/>
+          </a:effectRef>
+          <a:fontRef idx="minor">
+            <a:schemeClr val="tx1"/>
+          </a:fontRef>
+        </p:style>
+      </p:cxnSp>
     </p:spTree>
     <p:extLst>
       <p:ext uri="{BB962C8B-B14F-4D97-AF65-F5344CB8AC3E}">

</xml_diff>